<commit_message>
Update Slide 8 of AIvengers_KLA_PS01 presentation to feature official entry point command: python run.py <input-dir> <output-dir>
</commit_message>
<xml_diff>
--- a/AIvengers_KLA_PS01.pptx
+++ b/AIvengers_KLA_PS01.pptx
@@ -5088,19 +5088,31 @@
               </a:defRPr>
             </a:pPr>
             <a:r>
-              <a:t>Evaluation Script Usage Command:</a:t>
-            </a:r>
-          </a:p>
-          <a:p>
-            <a:pPr>
-              <a:defRPr sz="1400" b="1">
+              <a:t>Official Submission Entry Point:</a:t>
+            </a:r>
+          </a:p>
+          <a:p>
+            <a:pPr>
+              <a:defRPr sz="1600" b="1">
                 <a:solidFill>
                   <a:srgbClr val="00F0FF"/>
                 </a:solidFill>
               </a:defRPr>
             </a:pPr>
             <a:r>
-              <a:t>python evaluation.py --input &lt;test_images_directory&gt; --output &lt;restored_output_directory&gt;</a:t>
+              <a:t>python run.py &lt;input-dir&gt; &lt;output-dir&gt;</a:t>
+            </a:r>
+          </a:p>
+          <a:p>
+            <a:pPr>
+              <a:defRPr sz="1200">
+                <a:solidFill>
+                  <a:srgbClr val="A0AEC0"/>
+                </a:solidFill>
+              </a:defRPr>
+            </a:pPr>
+            <a:r>
+              <a:t>Processes all .npy inputs and generates corresponding restored .npy outputs.</a:t>
             </a:r>
           </a:p>
         </p:txBody>

</xml_diff>